<commit_message>
Fathah decks: beginning/middle/end forms for joining letters, unique background theme per deck
Co-Authored-By: Claude Sonnet 5.5 <noreply@anthropic.com>
Claude-Session: https://claude.ai/code/session_01FzFnzdoj1sJJKm8jQJSfJE
</commit_message>
<xml_diff>
--- a/all-letters/01-alif.pptx
+++ b/all-letters/01-alif.pptx
@@ -2173,7 +2173,7 @@
       </p:sp>
       <p:sp>
         <p:nvSpPr>
-          <p:cNvPr id="4" name="Deco sun"/>
+          <p:cNvPr id="4" name="Deco top left"/>
           <p:cNvSpPr/>
           <p:nvPr/>
         </p:nvSpPr>
@@ -2248,7 +2248,7 @@
       </p:sp>
       <p:sp>
         <p:nvSpPr>
-          <p:cNvPr id="7" name="Deco friend pink"/>
+          <p:cNvPr id="7" name="Deco friend left"/>
           <p:cNvSpPr/>
           <p:nvPr/>
         </p:nvSpPr>
@@ -2273,7 +2273,7 @@
       </p:sp>
       <p:sp>
         <p:nvSpPr>
-          <p:cNvPr id="8" name="Deco friend orange"/>
+          <p:cNvPr id="8" name="Deco friend right"/>
           <p:cNvSpPr/>
           <p:nvPr/>
         </p:nvSpPr>
@@ -2698,7 +2698,7 @@
       </p:sp>
       <p:sp>
         <p:nvSpPr>
-          <p:cNvPr id="4" name="Deco sun"/>
+          <p:cNvPr id="4" name="Deco top left"/>
           <p:cNvSpPr/>
           <p:nvPr/>
         </p:nvSpPr>
@@ -2773,7 +2773,7 @@
       </p:sp>
       <p:sp>
         <p:nvSpPr>
-          <p:cNvPr id="7" name="Deco friend pink"/>
+          <p:cNvPr id="7" name="Deco friend left"/>
           <p:cNvSpPr/>
           <p:nvPr/>
         </p:nvSpPr>
@@ -2798,7 +2798,7 @@
       </p:sp>
       <p:sp>
         <p:nvSpPr>
-          <p:cNvPr id="8" name="Deco friend orange"/>
+          <p:cNvPr id="8" name="Deco friend right"/>
           <p:cNvSpPr/>
           <p:nvPr/>
         </p:nvSpPr>
@@ -4002,7 +4002,7 @@
       </p:sp>
       <p:sp>
         <p:nvSpPr>
-          <p:cNvPr id="4" name="Deco sun"/>
+          <p:cNvPr id="4" name="Deco top left"/>
           <p:cNvSpPr/>
           <p:nvPr/>
         </p:nvSpPr>
@@ -4077,7 +4077,7 @@
       </p:sp>
       <p:sp>
         <p:nvSpPr>
-          <p:cNvPr id="7" name="Deco friend pink"/>
+          <p:cNvPr id="7" name="Deco friend left"/>
           <p:cNvSpPr/>
           <p:nvPr/>
         </p:nvSpPr>
@@ -4102,7 +4102,7 @@
       </p:sp>
       <p:sp>
         <p:nvSpPr>
-          <p:cNvPr id="8" name="Deco friend orange"/>
+          <p:cNvPr id="8" name="Deco friend right"/>
           <p:cNvSpPr/>
           <p:nvPr/>
         </p:nvSpPr>
@@ -5306,7 +5306,7 @@
       </p:sp>
       <p:sp>
         <p:nvSpPr>
-          <p:cNvPr id="4" name="Deco sun"/>
+          <p:cNvPr id="4" name="Deco top left"/>
           <p:cNvSpPr/>
           <p:nvPr/>
         </p:nvSpPr>
@@ -5381,7 +5381,7 @@
       </p:sp>
       <p:sp>
         <p:nvSpPr>
-          <p:cNvPr id="7" name="Deco friend pink"/>
+          <p:cNvPr id="7" name="Deco friend left"/>
           <p:cNvSpPr/>
           <p:nvPr/>
         </p:nvSpPr>
@@ -5406,7 +5406,7 @@
       </p:sp>
       <p:sp>
         <p:nvSpPr>
-          <p:cNvPr id="8" name="Deco friend orange"/>
+          <p:cNvPr id="8" name="Deco friend right"/>
           <p:cNvSpPr/>
           <p:nvPr/>
         </p:nvSpPr>
@@ -6610,7 +6610,7 @@
       </p:sp>
       <p:sp>
         <p:nvSpPr>
-          <p:cNvPr id="4" name="Deco sun"/>
+          <p:cNvPr id="4" name="Deco top left"/>
           <p:cNvSpPr/>
           <p:nvPr/>
         </p:nvSpPr>
@@ -6685,7 +6685,7 @@
       </p:sp>
       <p:sp>
         <p:nvSpPr>
-          <p:cNvPr id="7" name="Deco friend pink"/>
+          <p:cNvPr id="7" name="Deco friend left"/>
           <p:cNvSpPr/>
           <p:nvPr/>
         </p:nvSpPr>
@@ -6710,7 +6710,7 @@
       </p:sp>
       <p:sp>
         <p:nvSpPr>
-          <p:cNvPr id="8" name="Deco friend orange"/>
+          <p:cNvPr id="8" name="Deco friend right"/>
           <p:cNvSpPr/>
           <p:nvPr/>
         </p:nvSpPr>
@@ -7914,7 +7914,7 @@
       </p:sp>
       <p:sp>
         <p:nvSpPr>
-          <p:cNvPr id="4" name="Deco sun"/>
+          <p:cNvPr id="4" name="Deco top left"/>
           <p:cNvSpPr/>
           <p:nvPr/>
         </p:nvSpPr>
@@ -7989,7 +7989,7 @@
       </p:sp>
       <p:sp>
         <p:nvSpPr>
-          <p:cNvPr id="7" name="Deco friend pink"/>
+          <p:cNvPr id="7" name="Deco friend left"/>
           <p:cNvSpPr/>
           <p:nvPr/>
         </p:nvSpPr>
@@ -8014,7 +8014,7 @@
       </p:sp>
       <p:sp>
         <p:nvSpPr>
-          <p:cNvPr id="8" name="Deco friend orange"/>
+          <p:cNvPr id="8" name="Deco friend right"/>
           <p:cNvSpPr/>
           <p:nvPr/>
         </p:nvSpPr>
@@ -9218,7 +9218,7 @@
       </p:sp>
       <p:sp>
         <p:nvSpPr>
-          <p:cNvPr id="4" name="Deco sun"/>
+          <p:cNvPr id="4" name="Deco top left"/>
           <p:cNvSpPr/>
           <p:nvPr/>
         </p:nvSpPr>
@@ -9293,7 +9293,7 @@
       </p:sp>
       <p:sp>
         <p:nvSpPr>
-          <p:cNvPr id="7" name="Deco friend pink"/>
+          <p:cNvPr id="7" name="Deco friend left"/>
           <p:cNvSpPr/>
           <p:nvPr/>
         </p:nvSpPr>
@@ -9318,7 +9318,7 @@
       </p:sp>
       <p:sp>
         <p:nvSpPr>
-          <p:cNvPr id="8" name="Deco friend orange"/>
+          <p:cNvPr id="8" name="Deco friend right"/>
           <p:cNvSpPr/>
           <p:nvPr/>
         </p:nvSpPr>
@@ -10522,7 +10522,7 @@
       </p:sp>
       <p:sp>
         <p:nvSpPr>
-          <p:cNvPr id="4" name="Deco sun"/>
+          <p:cNvPr id="4" name="Deco top left"/>
           <p:cNvSpPr/>
           <p:nvPr/>
         </p:nvSpPr>
@@ -10597,7 +10597,7 @@
       </p:sp>
       <p:sp>
         <p:nvSpPr>
-          <p:cNvPr id="7" name="Deco friend pink"/>
+          <p:cNvPr id="7" name="Deco friend left"/>
           <p:cNvSpPr/>
           <p:nvPr/>
         </p:nvSpPr>
@@ -10622,7 +10622,7 @@
       </p:sp>
       <p:sp>
         <p:nvSpPr>
-          <p:cNvPr id="8" name="Deco friend orange"/>
+          <p:cNvPr id="8" name="Deco friend right"/>
           <p:cNvSpPr/>
           <p:nvPr/>
         </p:nvSpPr>
@@ -10880,7 +10880,7 @@
                 <a:ea typeface="Arial" pitchFamily="34" charset="-122"/>
                 <a:cs typeface="Arial" pitchFamily="34" charset="-120"/>
               </a:rPr>
-              <a:t>ب</a:t>
+              <a:t>س</a:t>
             </a:r>
             <a:endParaRPr lang="ar-SA" sz="9000" dirty="0"/>
           </a:p>
@@ -10919,7 +10919,7 @@
                 <a:ea typeface="Arial" pitchFamily="34" charset="-122"/>
                 <a:cs typeface="Arial" pitchFamily="34" charset="-120"/>
               </a:rPr>
-              <a:t>بَ</a:t>
+              <a:t>سَ</a:t>
             </a:r>
             <a:endParaRPr lang="ar-SA" sz="9000" dirty="0"/>
           </a:p>
@@ -11036,7 +11036,7 @@
                 <a:ea typeface="Arial" pitchFamily="34" charset="-122"/>
                 <a:cs typeface="Arial" pitchFamily="34" charset="-120"/>
               </a:rPr>
-              <a:t>بَأَ</a:t>
+              <a:t>سَأَ</a:t>
             </a:r>
             <a:endParaRPr lang="ar-SA" sz="9600" dirty="0"/>
           </a:p>
@@ -11536,7 +11536,7 @@
       </p:sp>
       <p:sp>
         <p:nvSpPr>
-          <p:cNvPr id="4" name="Deco sun"/>
+          <p:cNvPr id="4" name="Deco top left"/>
           <p:cNvSpPr/>
           <p:nvPr/>
         </p:nvSpPr>
@@ -11611,7 +11611,7 @@
       </p:sp>
       <p:sp>
         <p:nvSpPr>
-          <p:cNvPr id="7" name="Deco friend pink"/>
+          <p:cNvPr id="7" name="Deco friend left"/>
           <p:cNvSpPr/>
           <p:nvPr/>
         </p:nvSpPr>
@@ -11636,7 +11636,7 @@
       </p:sp>
       <p:sp>
         <p:nvSpPr>
-          <p:cNvPr id="8" name="Deco friend orange"/>
+          <p:cNvPr id="8" name="Deco friend right"/>
           <p:cNvSpPr/>
           <p:nvPr/>
         </p:nvSpPr>
@@ -11894,7 +11894,7 @@
                 <a:ea typeface="Arial" pitchFamily="34" charset="-122"/>
                 <a:cs typeface="Arial" pitchFamily="34" charset="-120"/>
               </a:rPr>
-              <a:t>ت</a:t>
+              <a:t>ب</a:t>
             </a:r>
             <a:endParaRPr lang="ar-SA" sz="9000" dirty="0"/>
           </a:p>
@@ -11933,7 +11933,7 @@
                 <a:ea typeface="Arial" pitchFamily="34" charset="-122"/>
                 <a:cs typeface="Arial" pitchFamily="34" charset="-120"/>
               </a:rPr>
-              <a:t>تَ</a:t>
+              <a:t>بَ</a:t>
             </a:r>
             <a:endParaRPr lang="ar-SA" sz="9000" dirty="0"/>
           </a:p>
@@ -12050,7 +12050,7 @@
                 <a:ea typeface="Arial" pitchFamily="34" charset="-122"/>
                 <a:cs typeface="Arial" pitchFamily="34" charset="-120"/>
               </a:rPr>
-              <a:t>تَأَ</a:t>
+              <a:t>بَأَ</a:t>
             </a:r>
             <a:endParaRPr lang="ar-SA" sz="9600" dirty="0"/>
           </a:p>
@@ -12550,7 +12550,7 @@
       </p:sp>
       <p:sp>
         <p:nvSpPr>
-          <p:cNvPr id="4" name="Deco sun"/>
+          <p:cNvPr id="4" name="Deco top left"/>
           <p:cNvSpPr/>
           <p:nvPr/>
         </p:nvSpPr>
@@ -12625,7 +12625,7 @@
       </p:sp>
       <p:sp>
         <p:nvSpPr>
-          <p:cNvPr id="7" name="Deco friend pink"/>
+          <p:cNvPr id="7" name="Deco friend left"/>
           <p:cNvSpPr/>
           <p:nvPr/>
         </p:nvSpPr>
@@ -12650,7 +12650,7 @@
       </p:sp>
       <p:sp>
         <p:nvSpPr>
-          <p:cNvPr id="8" name="Deco friend orange"/>
+          <p:cNvPr id="8" name="Deco friend right"/>
           <p:cNvSpPr/>
           <p:nvPr/>
         </p:nvSpPr>
@@ -12908,7 +12908,7 @@
                 <a:ea typeface="Arial" pitchFamily="34" charset="-122"/>
                 <a:cs typeface="Arial" pitchFamily="34" charset="-120"/>
               </a:rPr>
-              <a:t>ث</a:t>
+              <a:t>ت</a:t>
             </a:r>
             <a:endParaRPr lang="ar-SA" sz="9000" dirty="0"/>
           </a:p>
@@ -12947,7 +12947,7 @@
                 <a:ea typeface="Arial" pitchFamily="34" charset="-122"/>
                 <a:cs typeface="Arial" pitchFamily="34" charset="-120"/>
               </a:rPr>
-              <a:t>ثَ</a:t>
+              <a:t>تَ</a:t>
             </a:r>
             <a:endParaRPr lang="ar-SA" sz="9000" dirty="0"/>
           </a:p>
@@ -13064,7 +13064,7 @@
                 <a:ea typeface="Arial" pitchFamily="34" charset="-122"/>
                 <a:cs typeface="Arial" pitchFamily="34" charset="-120"/>
               </a:rPr>
-              <a:t>ثَأَ</a:t>
+              <a:t>تَأَ</a:t>
             </a:r>
             <a:endParaRPr lang="ar-SA" sz="9600" dirty="0"/>
           </a:p>
@@ -13564,7 +13564,7 @@
       </p:sp>
       <p:sp>
         <p:nvSpPr>
-          <p:cNvPr id="4" name="Deco sun"/>
+          <p:cNvPr id="4" name="Deco top left"/>
           <p:cNvSpPr/>
           <p:nvPr/>
         </p:nvSpPr>
@@ -13639,7 +13639,7 @@
       </p:sp>
       <p:sp>
         <p:nvSpPr>
-          <p:cNvPr id="7" name="Deco friend pink"/>
+          <p:cNvPr id="7" name="Deco friend left"/>
           <p:cNvSpPr/>
           <p:nvPr/>
         </p:nvSpPr>
@@ -13664,7 +13664,7 @@
       </p:sp>
       <p:sp>
         <p:nvSpPr>
-          <p:cNvPr id="8" name="Deco friend orange"/>
+          <p:cNvPr id="8" name="Deco friend right"/>
           <p:cNvSpPr/>
           <p:nvPr/>
         </p:nvSpPr>
@@ -13922,7 +13922,7 @@
                 <a:ea typeface="Arial" pitchFamily="34" charset="-122"/>
                 <a:cs typeface="Arial" pitchFamily="34" charset="-120"/>
               </a:rPr>
-              <a:t>ج</a:t>
+              <a:t>ث</a:t>
             </a:r>
             <a:endParaRPr lang="ar-SA" sz="9000" dirty="0"/>
           </a:p>
@@ -13961,7 +13961,7 @@
                 <a:ea typeface="Arial" pitchFamily="34" charset="-122"/>
                 <a:cs typeface="Arial" pitchFamily="34" charset="-120"/>
               </a:rPr>
-              <a:t>جَ</a:t>
+              <a:t>ثَ</a:t>
             </a:r>
             <a:endParaRPr lang="ar-SA" sz="9000" dirty="0"/>
           </a:p>
@@ -14078,7 +14078,7 @@
                 <a:ea typeface="Arial" pitchFamily="34" charset="-122"/>
                 <a:cs typeface="Arial" pitchFamily="34" charset="-120"/>
               </a:rPr>
-              <a:t>جَأَ</a:t>
+              <a:t>ثَأَ</a:t>
             </a:r>
             <a:endParaRPr lang="ar-SA" sz="9600" dirty="0"/>
           </a:p>
@@ -14578,7 +14578,7 @@
       </p:sp>
       <p:sp>
         <p:nvSpPr>
-          <p:cNvPr id="4" name="Deco sun"/>
+          <p:cNvPr id="4" name="Deco top left"/>
           <p:cNvSpPr/>
           <p:nvPr/>
         </p:nvSpPr>
@@ -14653,7 +14653,7 @@
       </p:sp>
       <p:sp>
         <p:nvSpPr>
-          <p:cNvPr id="7" name="Deco friend pink"/>
+          <p:cNvPr id="7" name="Deco friend left"/>
           <p:cNvSpPr/>
           <p:nvPr/>
         </p:nvSpPr>
@@ -14678,7 +14678,7 @@
       </p:sp>
       <p:sp>
         <p:nvSpPr>
-          <p:cNvPr id="8" name="Deco friend orange"/>
+          <p:cNvPr id="8" name="Deco friend right"/>
           <p:cNvSpPr/>
           <p:nvPr/>
         </p:nvSpPr>
@@ -14936,7 +14936,7 @@
                 <a:ea typeface="Arial" pitchFamily="34" charset="-122"/>
                 <a:cs typeface="Arial" pitchFamily="34" charset="-120"/>
               </a:rPr>
-              <a:t>ح</a:t>
+              <a:t>ج</a:t>
             </a:r>
             <a:endParaRPr lang="ar-SA" sz="9000" dirty="0"/>
           </a:p>
@@ -14975,7 +14975,7 @@
                 <a:ea typeface="Arial" pitchFamily="34" charset="-122"/>
                 <a:cs typeface="Arial" pitchFamily="34" charset="-120"/>
               </a:rPr>
-              <a:t>حَ</a:t>
+              <a:t>جَ</a:t>
             </a:r>
             <a:endParaRPr lang="ar-SA" sz="9000" dirty="0"/>
           </a:p>
@@ -15092,7 +15092,7 @@
                 <a:ea typeface="Arial" pitchFamily="34" charset="-122"/>
                 <a:cs typeface="Arial" pitchFamily="34" charset="-120"/>
               </a:rPr>
-              <a:t>حَأَ</a:t>
+              <a:t>جَأَ</a:t>
             </a:r>
             <a:endParaRPr lang="ar-SA" sz="9600" dirty="0"/>
           </a:p>
@@ -15592,7 +15592,7 @@
       </p:sp>
       <p:sp>
         <p:nvSpPr>
-          <p:cNvPr id="4" name="Deco sun"/>
+          <p:cNvPr id="4" name="Deco top left"/>
           <p:cNvSpPr/>
           <p:nvPr/>
         </p:nvSpPr>
@@ -15667,7 +15667,7 @@
       </p:sp>
       <p:sp>
         <p:nvSpPr>
-          <p:cNvPr id="7" name="Deco friend pink"/>
+          <p:cNvPr id="7" name="Deco friend left"/>
           <p:cNvSpPr/>
           <p:nvPr/>
         </p:nvSpPr>
@@ -15692,7 +15692,7 @@
       </p:sp>
       <p:sp>
         <p:nvSpPr>
-          <p:cNvPr id="8" name="Deco friend orange"/>
+          <p:cNvPr id="8" name="Deco friend right"/>
           <p:cNvSpPr/>
           <p:nvPr/>
         </p:nvSpPr>
@@ -15950,7 +15950,7 @@
                 <a:ea typeface="Arial" pitchFamily="34" charset="-122"/>
                 <a:cs typeface="Arial" pitchFamily="34" charset="-120"/>
               </a:rPr>
-              <a:t>خ</a:t>
+              <a:t>ح</a:t>
             </a:r>
             <a:endParaRPr lang="ar-SA" sz="9000" dirty="0"/>
           </a:p>
@@ -15989,7 +15989,7 @@
                 <a:ea typeface="Arial" pitchFamily="34" charset="-122"/>
                 <a:cs typeface="Arial" pitchFamily="34" charset="-120"/>
               </a:rPr>
-              <a:t>خَ</a:t>
+              <a:t>حَ</a:t>
             </a:r>
             <a:endParaRPr lang="ar-SA" sz="9000" dirty="0"/>
           </a:p>
@@ -16106,7 +16106,7 @@
                 <a:ea typeface="Arial" pitchFamily="34" charset="-122"/>
                 <a:cs typeface="Arial" pitchFamily="34" charset="-120"/>
               </a:rPr>
-              <a:t>خَأَ</a:t>
+              <a:t>حَأَ</a:t>
             </a:r>
             <a:endParaRPr lang="ar-SA" sz="9600" dirty="0"/>
           </a:p>
@@ -16606,7 +16606,7 @@
       </p:sp>
       <p:sp>
         <p:nvSpPr>
-          <p:cNvPr id="4" name="Deco sun"/>
+          <p:cNvPr id="4" name="Deco top left"/>
           <p:cNvSpPr/>
           <p:nvPr/>
         </p:nvSpPr>
@@ -16681,7 +16681,7 @@
       </p:sp>
       <p:sp>
         <p:nvSpPr>
-          <p:cNvPr id="7" name="Deco friend pink"/>
+          <p:cNvPr id="7" name="Deco friend left"/>
           <p:cNvSpPr/>
           <p:nvPr/>
         </p:nvSpPr>
@@ -16706,7 +16706,7 @@
       </p:sp>
       <p:sp>
         <p:nvSpPr>
-          <p:cNvPr id="8" name="Deco friend orange"/>
+          <p:cNvPr id="8" name="Deco friend right"/>
           <p:cNvSpPr/>
           <p:nvPr/>
         </p:nvSpPr>
@@ -16964,7 +16964,7 @@
                 <a:ea typeface="Arial" pitchFamily="34" charset="-122"/>
                 <a:cs typeface="Arial" pitchFamily="34" charset="-120"/>
               </a:rPr>
-              <a:t>د</a:t>
+              <a:t>خ</a:t>
             </a:r>
             <a:endParaRPr lang="ar-SA" sz="9000" dirty="0"/>
           </a:p>
@@ -17003,7 +17003,7 @@
                 <a:ea typeface="Arial" pitchFamily="34" charset="-122"/>
                 <a:cs typeface="Arial" pitchFamily="34" charset="-120"/>
               </a:rPr>
-              <a:t>دَ</a:t>
+              <a:t>خَ</a:t>
             </a:r>
             <a:endParaRPr lang="ar-SA" sz="9000" dirty="0"/>
           </a:p>
@@ -17120,7 +17120,7 @@
                 <a:ea typeface="Arial" pitchFamily="34" charset="-122"/>
                 <a:cs typeface="Arial" pitchFamily="34" charset="-120"/>
               </a:rPr>
-              <a:t>دَأَ</a:t>
+              <a:t>خَأَ</a:t>
             </a:r>
             <a:endParaRPr lang="ar-SA" sz="9600" dirty="0"/>
           </a:p>
@@ -17620,7 +17620,7 @@
       </p:sp>
       <p:sp>
         <p:nvSpPr>
-          <p:cNvPr id="4" name="Deco sun"/>
+          <p:cNvPr id="4" name="Deco top left"/>
           <p:cNvSpPr/>
           <p:nvPr/>
         </p:nvSpPr>
@@ -17695,7 +17695,7 @@
       </p:sp>
       <p:sp>
         <p:nvSpPr>
-          <p:cNvPr id="7" name="Deco friend pink"/>
+          <p:cNvPr id="7" name="Deco friend left"/>
           <p:cNvSpPr/>
           <p:nvPr/>
         </p:nvSpPr>
@@ -17720,7 +17720,7 @@
       </p:sp>
       <p:sp>
         <p:nvSpPr>
-          <p:cNvPr id="8" name="Deco friend orange"/>
+          <p:cNvPr id="8" name="Deco friend right"/>
           <p:cNvSpPr/>
           <p:nvPr/>
         </p:nvSpPr>

</xml_diff>